<commit_message>
Removed the slides 2 and 3.
</commit_message>
<xml_diff>
--- a/Steganography Project.pptx
+++ b/Steganography Project.pptx
@@ -6,12 +6,10 @@
   </p:sldMasterIdLst>
   <p:sldIdLst>
     <p:sldId id="256" r:id="rId2"/>
-    <p:sldId id="257" r:id="rId3"/>
-    <p:sldId id="258" r:id="rId4"/>
-    <p:sldId id="259" r:id="rId5"/>
-    <p:sldId id="260" r:id="rId6"/>
-    <p:sldId id="261" r:id="rId7"/>
-    <p:sldId id="262" r:id="rId8"/>
+    <p:sldId id="259" r:id="rId3"/>
+    <p:sldId id="260" r:id="rId4"/>
+    <p:sldId id="261" r:id="rId5"/>
+    <p:sldId id="262" r:id="rId6"/>
   </p:sldIdLst>
   <p:sldSz cx="12192000" cy="6858000"/>
   <p:notesSz cx="6858000" cy="9144000"/>
@@ -286,7 +284,7 @@
           <a:p>
             <a:fld id="{BB668030-A114-4385-8D34-D6535427301A}" type="datetimeFigureOut">
               <a:rPr lang="en-US" smtClean="0"/>
-              <a:t>6/19/2026</a:t>
+              <a:t>6/18/2026</a:t>
             </a:fld>
             <a:endParaRPr lang="en-US"/>
           </a:p>
@@ -391,6 +389,13 @@
             <a:schemeClr val="lt1"/>
           </a:fontRef>
         </p:style>
+        <p:txBody>
+          <a:bodyPr/>
+          <a:lstStyle/>
+          <a:p>
+            <a:endParaRPr lang="en-CA"/>
+          </a:p>
+        </p:txBody>
       </p:sp>
     </p:spTree>
     <p:extLst>
@@ -514,7 +519,7 @@
           <a:p>
             <a:fld id="{BB668030-A114-4385-8D34-D6535427301A}" type="datetimeFigureOut">
               <a:rPr lang="en-US" smtClean="0"/>
-              <a:t>6/19/2026</a:t>
+              <a:t>6/18/2026</a:t>
             </a:fld>
             <a:endParaRPr lang="en-US"/>
           </a:p>
@@ -694,7 +699,7 @@
           <a:p>
             <a:fld id="{BB668030-A114-4385-8D34-D6535427301A}" type="datetimeFigureOut">
               <a:rPr lang="en-US" smtClean="0"/>
-              <a:t>6/19/2026</a:t>
+              <a:t>6/18/2026</a:t>
             </a:fld>
             <a:endParaRPr lang="en-US"/>
           </a:p>
@@ -864,7 +869,7 @@
           <a:p>
             <a:fld id="{BB668030-A114-4385-8D34-D6535427301A}" type="datetimeFigureOut">
               <a:rPr lang="en-US" smtClean="0"/>
-              <a:t>6/19/2026</a:t>
+              <a:t>6/18/2026</a:t>
             </a:fld>
             <a:endParaRPr lang="en-US"/>
           </a:p>
@@ -1118,7 +1123,7 @@
           <a:p>
             <a:fld id="{BB668030-A114-4385-8D34-D6535427301A}" type="datetimeFigureOut">
               <a:rPr lang="en-US" smtClean="0"/>
-              <a:t>6/19/2026</a:t>
+              <a:t>6/18/2026</a:t>
             </a:fld>
             <a:endParaRPr lang="en-US"/>
           </a:p>
@@ -1444,7 +1449,7 @@
           <a:p>
             <a:fld id="{BB668030-A114-4385-8D34-D6535427301A}" type="datetimeFigureOut">
               <a:rPr lang="en-US" smtClean="0"/>
-              <a:t>6/19/2026</a:t>
+              <a:t>6/18/2026</a:t>
             </a:fld>
             <a:endParaRPr lang="en-US"/>
           </a:p>
@@ -1895,7 +1900,7 @@
           <a:p>
             <a:fld id="{BB668030-A114-4385-8D34-D6535427301A}" type="datetimeFigureOut">
               <a:rPr lang="en-US" smtClean="0"/>
-              <a:t>6/19/2026</a:t>
+              <a:t>6/18/2026</a:t>
             </a:fld>
             <a:endParaRPr lang="en-US"/>
           </a:p>
@@ -2013,7 +2018,7 @@
           <a:p>
             <a:fld id="{BB668030-A114-4385-8D34-D6535427301A}" type="datetimeFigureOut">
               <a:rPr lang="en-US" smtClean="0"/>
-              <a:t>6/19/2026</a:t>
+              <a:t>6/18/2026</a:t>
             </a:fld>
             <a:endParaRPr lang="en-US"/>
           </a:p>
@@ -2108,7 +2113,7 @@
           <a:p>
             <a:fld id="{BB668030-A114-4385-8D34-D6535427301A}" type="datetimeFigureOut">
               <a:rPr lang="en-US" smtClean="0"/>
-              <a:t>6/19/2026</a:t>
+              <a:t>6/18/2026</a:t>
             </a:fld>
             <a:endParaRPr lang="en-US"/>
           </a:p>
@@ -2395,7 +2400,7 @@
           <a:p>
             <a:fld id="{BB668030-A114-4385-8D34-D6535427301A}" type="datetimeFigureOut">
               <a:rPr lang="en-US" smtClean="0"/>
-              <a:t>6/19/2026</a:t>
+              <a:t>6/18/2026</a:t>
             </a:fld>
             <a:endParaRPr lang="en-US"/>
           </a:p>
@@ -2717,7 +2722,7 @@
           <a:p>
             <a:fld id="{BB668030-A114-4385-8D34-D6535427301A}" type="datetimeFigureOut">
               <a:rPr lang="en-US" smtClean="0"/>
-              <a:t>6/19/2026</a:t>
+              <a:t>6/18/2026</a:t>
             </a:fld>
             <a:endParaRPr lang="en-US"/>
           </a:p>
@@ -2839,6 +2844,13 @@
             <a:schemeClr val="lt1"/>
           </a:fontRef>
         </p:style>
+        <p:txBody>
+          <a:bodyPr/>
+          <a:lstStyle/>
+          <a:p>
+            <a:endParaRPr lang="en-CA"/>
+          </a:p>
+        </p:txBody>
       </p:sp>
       <p:sp>
         <p:nvSpPr>
@@ -2971,7 +2983,7 @@
           <a:p>
             <a:fld id="{BB668030-A114-4385-8D34-D6535427301A}" type="datetimeFigureOut">
               <a:rPr lang="en-US" smtClean="0"/>
-              <a:t>6/19/2026</a:t>
+              <a:t>6/18/2026</a:t>
             </a:fld>
             <a:endParaRPr lang="en-US"/>
           </a:p>
@@ -3599,7 +3611,7 @@
           <p:cNvPr id="2" name="Title 1">
             <a:extLst>
               <a:ext uri="{FF2B5EF4-FFF2-40B4-BE49-F238E27FC236}">
-                <a16:creationId xmlns:a16="http://schemas.microsoft.com/office/drawing/2014/main" id="{99FA3EE0-D76D-4728-90B4-0759F1522A3A}"/>
+                <a16:creationId xmlns:a16="http://schemas.microsoft.com/office/drawing/2014/main" id="{8F6202FE-B970-49D9-9AE5-ABBD591B46CA}"/>
               </a:ext>
             </a:extLst>
           </p:cNvPr>
@@ -3612,8 +3624,8 @@
         </p:nvSpPr>
         <p:spPr>
           <a:xfrm>
-            <a:off x="1261872" y="365760"/>
-            <a:ext cx="9692640" cy="785016"/>
+            <a:off x="1249680" y="497633"/>
+            <a:ext cx="9692640" cy="714718"/>
           </a:xfrm>
         </p:spPr>
         <p:txBody>
@@ -3622,7 +3634,7 @@
           <a:p>
             <a:r>
               <a:rPr lang="en-US" dirty="0"/>
-              <a:t>Information Security (InfoSec)</a:t>
+              <a:t>What is Steganography?</a:t>
             </a:r>
           </a:p>
         </p:txBody>
@@ -3632,7 +3644,7 @@
           <p:cNvPr id="3" name="Content Placeholder 2">
             <a:extLst>
               <a:ext uri="{FF2B5EF4-FFF2-40B4-BE49-F238E27FC236}">
-                <a16:creationId xmlns:a16="http://schemas.microsoft.com/office/drawing/2014/main" id="{E53EDB01-43F5-4701-A75B-E43BEBCFC58C}"/>
+                <a16:creationId xmlns:a16="http://schemas.microsoft.com/office/drawing/2014/main" id="{BD54AFDD-7AF9-4A73-B0F8-8FE6C1072BE0}"/>
               </a:ext>
             </a:extLst>
           </p:cNvPr>
@@ -3652,35 +3664,8 @@
               <a:buNone/>
             </a:pPr>
             <a:r>
-              <a:rPr lang="en-US" b="1" dirty="0"/>
-              <a:t>What is Information Security?</a:t>
-            </a:r>
-          </a:p>
-          <a:p>
-            <a:pPr marL="0" indent="0">
-              <a:buNone/>
-            </a:pPr>
-            <a:r>
               <a:rPr lang="en-US" dirty="0"/>
-              <a:t>Information Security (InfoSec) is the practice of protecting information from unauthorized access, modification, disclosure, or destruction.</a:t>
-            </a:r>
-          </a:p>
-          <a:p>
-            <a:pPr marL="0" indent="0">
-              <a:buNone/>
-            </a:pPr>
-            <a:r>
-              <a:rPr lang="en-US" dirty="0"/>
-              <a:t>The main goal of information security is to protect valuable data and ensure that it remains secure.</a:t>
-            </a:r>
-          </a:p>
-          <a:p>
-            <a:pPr marL="0" indent="0">
-              <a:buNone/>
-            </a:pPr>
-            <a:r>
-              <a:rPr lang="en-US" b="1" dirty="0"/>
-              <a:t>CIA Triad</a:t>
+              <a:t>Steganography is the art and science of hiding secret information inside another file, such as:</a:t>
             </a:r>
           </a:p>
           <a:p>
@@ -3689,12 +3674,8 @@
               <a:buChar char="•"/>
             </a:pPr>
             <a:r>
-              <a:rPr lang="en-US" b="1" dirty="0"/>
-              <a:t>Confidentiality</a:t>
-            </a:r>
-            <a:r>
               <a:rPr lang="en-US" dirty="0"/>
-              <a:t> – Protecting data from unauthorized access </a:t>
+              <a:t>Images </a:t>
             </a:r>
           </a:p>
           <a:p>
@@ -3703,12 +3684,8 @@
               <a:buChar char="•"/>
             </a:pPr>
             <a:r>
-              <a:rPr lang="en-US" b="1" dirty="0"/>
-              <a:t>Integrity</a:t>
-            </a:r>
-            <a:r>
               <a:rPr lang="en-US" dirty="0"/>
-              <a:t> – Maintaining data accuracy and consistency </a:t>
+              <a:t>Text files </a:t>
             </a:r>
           </a:p>
           <a:p>
@@ -3717,20 +3694,33 @@
               <a:buChar char="•"/>
             </a:pPr>
             <a:r>
-              <a:rPr lang="en-US" b="1" dirty="0"/>
-              <a:t>Availability</a:t>
-            </a:r>
-            <a:r>
               <a:rPr lang="en-US" dirty="0"/>
-              <a:t> – Ensuring data is accessible when </a:t>
-            </a:r>
-            <a:r>
-              <a:rPr lang="en-US" dirty="0" err="1"/>
-              <a:t>neede</a:t>
-            </a:r>
-            <a:endParaRPr lang="en-US" dirty="0"/>
-          </a:p>
-          <a:p>
+              <a:t>Audio files </a:t>
+            </a:r>
+          </a:p>
+          <a:p>
+            <a:pPr>
+              <a:buFont typeface="Arial" panose="020B0604020202020204" pitchFamily="34" charset="0"/>
+              <a:buChar char="•"/>
+            </a:pPr>
+            <a:r>
+              <a:rPr lang="en-US" dirty="0"/>
+              <a:t>Video files </a:t>
+            </a:r>
+          </a:p>
+          <a:p>
+            <a:pPr marL="0" indent="0">
+              <a:buNone/>
+            </a:pPr>
+            <a:r>
+              <a:rPr lang="en-US" dirty="0"/>
+              <a:t>The goal is to make the hidden information invisible to unauthorized users.</a:t>
+            </a:r>
+          </a:p>
+          <a:p>
+            <a:pPr marL="0" indent="0">
+              <a:buNone/>
+            </a:pPr>
             <a:endParaRPr lang="en-US" dirty="0"/>
           </a:p>
         </p:txBody>
@@ -3738,7 +3728,7 @@
     </p:spTree>
     <p:extLst>
       <p:ext uri="{BB962C8B-B14F-4D97-AF65-F5344CB8AC3E}">
-        <p14:creationId xmlns:p14="http://schemas.microsoft.com/office/powerpoint/2010/main" val="2115766422"/>
+        <p14:creationId xmlns:p14="http://schemas.microsoft.com/office/powerpoint/2010/main" val="2582285254"/>
       </p:ext>
     </p:extLst>
   </p:cSld>
@@ -3770,7 +3760,7 @@
           <p:cNvPr id="2" name="Title 1">
             <a:extLst>
               <a:ext uri="{FF2B5EF4-FFF2-40B4-BE49-F238E27FC236}">
-                <a16:creationId xmlns:a16="http://schemas.microsoft.com/office/drawing/2014/main" id="{FE6A4E59-E97E-48A4-BFC5-CADF73A4B7C8}"/>
+                <a16:creationId xmlns:a16="http://schemas.microsoft.com/office/drawing/2014/main" id="{B7A13D02-356C-4FEE-8E98-2C6DC0FCB9BC}"/>
               </a:ext>
             </a:extLst>
           </p:cNvPr>
@@ -3793,7 +3783,7 @@
           <a:p>
             <a:r>
               <a:rPr lang="en-US" dirty="0"/>
-              <a:t>Security Techniques</a:t>
+              <a:t>Types of Steganography</a:t>
             </a:r>
           </a:p>
         </p:txBody>
@@ -3803,7 +3793,7 @@
           <p:cNvPr id="3" name="Content Placeholder 2">
             <a:extLst>
               <a:ext uri="{FF2B5EF4-FFF2-40B4-BE49-F238E27FC236}">
-                <a16:creationId xmlns:a16="http://schemas.microsoft.com/office/drawing/2014/main" id="{72D8B036-A9B5-4F18-82FE-C4C92975DC34}"/>
+                <a16:creationId xmlns:a16="http://schemas.microsoft.com/office/drawing/2014/main" id="{018F7130-C8D1-434C-A4CC-404686E0E572}"/>
               </a:ext>
             </a:extLst>
           </p:cNvPr>
@@ -3819,18 +3809,24 @@
           <a:bodyPr/>
           <a:lstStyle/>
           <a:p>
+            <a:r>
+              <a:rPr lang="en-US" b="1" dirty="0"/>
+              <a:t>Text Steganography</a:t>
+            </a:r>
+          </a:p>
+          <a:p>
             <a:pPr marL="0" indent="0">
               <a:buNone/>
             </a:pPr>
             <a:r>
               <a:rPr lang="en-US" dirty="0"/>
-              <a:t>Several techniques are used to protect information:</a:t>
+              <a:t>Hiding information inside text documents.</a:t>
             </a:r>
           </a:p>
           <a:p>
             <a:r>
               <a:rPr lang="en-US" b="1" dirty="0"/>
-              <a:t>Encryption</a:t>
+              <a:t>Image Steganography</a:t>
             </a:r>
           </a:p>
           <a:p>
@@ -3839,13 +3835,13 @@
             </a:pPr>
             <a:r>
               <a:rPr lang="en-US" dirty="0"/>
-              <a:t>Converts readable information into an unreadable format.</a:t>
+              <a:t>Hiding information inside digital images.</a:t>
             </a:r>
           </a:p>
           <a:p>
             <a:r>
               <a:rPr lang="en-US" b="1" dirty="0"/>
-              <a:t>Authentication</a:t>
+              <a:t>Audio Steganography</a:t>
             </a:r>
           </a:p>
           <a:p>
@@ -3854,13 +3850,13 @@
             </a:pPr>
             <a:r>
               <a:rPr lang="en-US" dirty="0"/>
-              <a:t>Verifies the identity of users.</a:t>
+              <a:t>Hiding information inside audio files.</a:t>
             </a:r>
           </a:p>
           <a:p>
             <a:r>
               <a:rPr lang="en-US" b="1" dirty="0"/>
-              <a:t>Access Control</a:t>
+              <a:t>Video Steganography</a:t>
             </a:r>
           </a:p>
           <a:p>
@@ -3869,22 +3865,7 @@
             </a:pPr>
             <a:r>
               <a:rPr lang="en-US" dirty="0"/>
-              <a:t>Restricts access to authorized users only.</a:t>
-            </a:r>
-          </a:p>
-          <a:p>
-            <a:r>
-              <a:rPr lang="en-US" b="1" dirty="0"/>
-              <a:t>Steganography</a:t>
-            </a:r>
-          </a:p>
-          <a:p>
-            <a:pPr marL="0" indent="0">
-              <a:buNone/>
-            </a:pPr>
-            <a:r>
-              <a:rPr lang="en-US" dirty="0"/>
-              <a:t>Hides information inside another file or medium.</a:t>
+              <a:t>Hiding information inside videos.</a:t>
             </a:r>
           </a:p>
           <a:p>
@@ -3898,7 +3879,7 @@
     </p:spTree>
     <p:extLst>
       <p:ext uri="{BB962C8B-B14F-4D97-AF65-F5344CB8AC3E}">
-        <p14:creationId xmlns:p14="http://schemas.microsoft.com/office/powerpoint/2010/main" val="2321067214"/>
+        <p14:creationId xmlns:p14="http://schemas.microsoft.com/office/powerpoint/2010/main" val="3060488503"/>
       </p:ext>
     </p:extLst>
   </p:cSld>
@@ -3930,306 +3911,6 @@
           <p:cNvPr id="2" name="Title 1">
             <a:extLst>
               <a:ext uri="{FF2B5EF4-FFF2-40B4-BE49-F238E27FC236}">
-                <a16:creationId xmlns:a16="http://schemas.microsoft.com/office/drawing/2014/main" id="{8F6202FE-B970-49D9-9AE5-ABBD591B46CA}"/>
-              </a:ext>
-            </a:extLst>
-          </p:cNvPr>
-          <p:cNvSpPr>
-            <a:spLocks noGrp="1"/>
-          </p:cNvSpPr>
-          <p:nvPr>
-            <p:ph type="title"/>
-          </p:nvPr>
-        </p:nvSpPr>
-        <p:spPr>
-          <a:xfrm>
-            <a:off x="1249680" y="497633"/>
-            <a:ext cx="9692640" cy="714718"/>
-          </a:xfrm>
-        </p:spPr>
-        <p:txBody>
-          <a:bodyPr/>
-          <a:lstStyle/>
-          <a:p>
-            <a:r>
-              <a:rPr lang="en-US" dirty="0"/>
-              <a:t>What is Steganography?</a:t>
-            </a:r>
-          </a:p>
-        </p:txBody>
-      </p:sp>
-      <p:sp>
-        <p:nvSpPr>
-          <p:cNvPr id="3" name="Content Placeholder 2">
-            <a:extLst>
-              <a:ext uri="{FF2B5EF4-FFF2-40B4-BE49-F238E27FC236}">
-                <a16:creationId xmlns:a16="http://schemas.microsoft.com/office/drawing/2014/main" id="{BD54AFDD-7AF9-4A73-B0F8-8FE6C1072BE0}"/>
-              </a:ext>
-            </a:extLst>
-          </p:cNvPr>
-          <p:cNvSpPr>
-            <a:spLocks noGrp="1"/>
-          </p:cNvSpPr>
-          <p:nvPr>
-            <p:ph idx="1"/>
-          </p:nvPr>
-        </p:nvSpPr>
-        <p:spPr/>
-        <p:txBody>
-          <a:bodyPr/>
-          <a:lstStyle/>
-          <a:p>
-            <a:pPr marL="0" indent="0">
-              <a:buNone/>
-            </a:pPr>
-            <a:r>
-              <a:rPr lang="en-US" dirty="0"/>
-              <a:t>Steganography is the art and science of hiding secret information inside another file, such as:</a:t>
-            </a:r>
-          </a:p>
-          <a:p>
-            <a:pPr>
-              <a:buFont typeface="Arial" panose="020B0604020202020204" pitchFamily="34" charset="0"/>
-              <a:buChar char="•"/>
-            </a:pPr>
-            <a:r>
-              <a:rPr lang="en-US" dirty="0"/>
-              <a:t>Images </a:t>
-            </a:r>
-          </a:p>
-          <a:p>
-            <a:pPr>
-              <a:buFont typeface="Arial" panose="020B0604020202020204" pitchFamily="34" charset="0"/>
-              <a:buChar char="•"/>
-            </a:pPr>
-            <a:r>
-              <a:rPr lang="en-US" dirty="0"/>
-              <a:t>Text files </a:t>
-            </a:r>
-          </a:p>
-          <a:p>
-            <a:pPr>
-              <a:buFont typeface="Arial" panose="020B0604020202020204" pitchFamily="34" charset="0"/>
-              <a:buChar char="•"/>
-            </a:pPr>
-            <a:r>
-              <a:rPr lang="en-US" dirty="0"/>
-              <a:t>Audio files </a:t>
-            </a:r>
-          </a:p>
-          <a:p>
-            <a:pPr>
-              <a:buFont typeface="Arial" panose="020B0604020202020204" pitchFamily="34" charset="0"/>
-              <a:buChar char="•"/>
-            </a:pPr>
-            <a:r>
-              <a:rPr lang="en-US" dirty="0"/>
-              <a:t>Video files </a:t>
-            </a:r>
-          </a:p>
-          <a:p>
-            <a:pPr marL="0" indent="0">
-              <a:buNone/>
-            </a:pPr>
-            <a:r>
-              <a:rPr lang="en-US" dirty="0"/>
-              <a:t>The goal is to make the hidden information invisible to unauthorized users.</a:t>
-            </a:r>
-          </a:p>
-          <a:p>
-            <a:pPr marL="0" indent="0">
-              <a:buNone/>
-            </a:pPr>
-            <a:endParaRPr lang="en-US" dirty="0"/>
-          </a:p>
-        </p:txBody>
-      </p:sp>
-    </p:spTree>
-    <p:extLst>
-      <p:ext uri="{BB962C8B-B14F-4D97-AF65-F5344CB8AC3E}">
-        <p14:creationId xmlns:p14="http://schemas.microsoft.com/office/powerpoint/2010/main" val="2582285254"/>
-      </p:ext>
-    </p:extLst>
-  </p:cSld>
-  <p:clrMapOvr>
-    <a:masterClrMapping/>
-  </p:clrMapOvr>
-</p:sld>
-</file>
-
-<file path=ppt/slides/slide5.xml><?xml version="1.0" encoding="utf-8"?>
-<p:sld xmlns:a="http://schemas.openxmlformats.org/drawingml/2006/main" xmlns:r="http://schemas.openxmlformats.org/officeDocument/2006/relationships" xmlns:p="http://schemas.openxmlformats.org/presentationml/2006/main">
-  <p:cSld>
-    <p:spTree>
-      <p:nvGrpSpPr>
-        <p:cNvPr id="1" name=""/>
-        <p:cNvGrpSpPr/>
-        <p:nvPr/>
-      </p:nvGrpSpPr>
-      <p:grpSpPr>
-        <a:xfrm>
-          <a:off x="0" y="0"/>
-          <a:ext cx="0" cy="0"/>
-          <a:chOff x="0" y="0"/>
-          <a:chExt cx="0" cy="0"/>
-        </a:xfrm>
-      </p:grpSpPr>
-      <p:sp>
-        <p:nvSpPr>
-          <p:cNvPr id="2" name="Title 1">
-            <a:extLst>
-              <a:ext uri="{FF2B5EF4-FFF2-40B4-BE49-F238E27FC236}">
-                <a16:creationId xmlns:a16="http://schemas.microsoft.com/office/drawing/2014/main" id="{B7A13D02-356C-4FEE-8E98-2C6DC0FCB9BC}"/>
-              </a:ext>
-            </a:extLst>
-          </p:cNvPr>
-          <p:cNvSpPr>
-            <a:spLocks noGrp="1"/>
-          </p:cNvSpPr>
-          <p:nvPr>
-            <p:ph type="title"/>
-          </p:nvPr>
-        </p:nvSpPr>
-        <p:spPr>
-          <a:xfrm>
-            <a:off x="1261872" y="365760"/>
-            <a:ext cx="9692640" cy="735252"/>
-          </a:xfrm>
-        </p:spPr>
-        <p:txBody>
-          <a:bodyPr/>
-          <a:lstStyle/>
-          <a:p>
-            <a:r>
-              <a:rPr lang="en-US" dirty="0"/>
-              <a:t>Types of Steganography</a:t>
-            </a:r>
-          </a:p>
-        </p:txBody>
-      </p:sp>
-      <p:sp>
-        <p:nvSpPr>
-          <p:cNvPr id="3" name="Content Placeholder 2">
-            <a:extLst>
-              <a:ext uri="{FF2B5EF4-FFF2-40B4-BE49-F238E27FC236}">
-                <a16:creationId xmlns:a16="http://schemas.microsoft.com/office/drawing/2014/main" id="{018F7130-C8D1-434C-A4CC-404686E0E572}"/>
-              </a:ext>
-            </a:extLst>
-          </p:cNvPr>
-          <p:cNvSpPr>
-            <a:spLocks noGrp="1"/>
-          </p:cNvSpPr>
-          <p:nvPr>
-            <p:ph idx="1"/>
-          </p:nvPr>
-        </p:nvSpPr>
-        <p:spPr/>
-        <p:txBody>
-          <a:bodyPr/>
-          <a:lstStyle/>
-          <a:p>
-            <a:r>
-              <a:rPr lang="en-US" b="1" dirty="0"/>
-              <a:t>Text Steganography</a:t>
-            </a:r>
-          </a:p>
-          <a:p>
-            <a:pPr marL="0" indent="0">
-              <a:buNone/>
-            </a:pPr>
-            <a:r>
-              <a:rPr lang="en-US" dirty="0"/>
-              <a:t>Hiding information inside text documents.</a:t>
-            </a:r>
-          </a:p>
-          <a:p>
-            <a:r>
-              <a:rPr lang="en-US" b="1" dirty="0"/>
-              <a:t>Image Steganography</a:t>
-            </a:r>
-          </a:p>
-          <a:p>
-            <a:pPr marL="0" indent="0">
-              <a:buNone/>
-            </a:pPr>
-            <a:r>
-              <a:rPr lang="en-US" dirty="0"/>
-              <a:t>Hiding information inside digital images.</a:t>
-            </a:r>
-          </a:p>
-          <a:p>
-            <a:r>
-              <a:rPr lang="en-US" b="1" dirty="0"/>
-              <a:t>Audio Steganography</a:t>
-            </a:r>
-          </a:p>
-          <a:p>
-            <a:pPr marL="0" indent="0">
-              <a:buNone/>
-            </a:pPr>
-            <a:r>
-              <a:rPr lang="en-US" dirty="0"/>
-              <a:t>Hiding information inside audio files.</a:t>
-            </a:r>
-          </a:p>
-          <a:p>
-            <a:r>
-              <a:rPr lang="en-US" b="1" dirty="0"/>
-              <a:t>Video Steganography</a:t>
-            </a:r>
-          </a:p>
-          <a:p>
-            <a:pPr marL="0" indent="0">
-              <a:buNone/>
-            </a:pPr>
-            <a:r>
-              <a:rPr lang="en-US" dirty="0"/>
-              <a:t>Hiding information inside videos.</a:t>
-            </a:r>
-          </a:p>
-          <a:p>
-            <a:pPr marL="0" indent="0">
-              <a:buNone/>
-            </a:pPr>
-            <a:endParaRPr lang="en-US" dirty="0"/>
-          </a:p>
-        </p:txBody>
-      </p:sp>
-    </p:spTree>
-    <p:extLst>
-      <p:ext uri="{BB962C8B-B14F-4D97-AF65-F5344CB8AC3E}">
-        <p14:creationId xmlns:p14="http://schemas.microsoft.com/office/powerpoint/2010/main" val="3060488503"/>
-      </p:ext>
-    </p:extLst>
-  </p:cSld>
-  <p:clrMapOvr>
-    <a:masterClrMapping/>
-  </p:clrMapOvr>
-</p:sld>
-</file>
-
-<file path=ppt/slides/slide6.xml><?xml version="1.0" encoding="utf-8"?>
-<p:sld xmlns:a="http://schemas.openxmlformats.org/drawingml/2006/main" xmlns:r="http://schemas.openxmlformats.org/officeDocument/2006/relationships" xmlns:p="http://schemas.openxmlformats.org/presentationml/2006/main">
-  <p:cSld>
-    <p:spTree>
-      <p:nvGrpSpPr>
-        <p:cNvPr id="1" name=""/>
-        <p:cNvGrpSpPr/>
-        <p:nvPr/>
-      </p:nvGrpSpPr>
-      <p:grpSpPr>
-        <a:xfrm>
-          <a:off x="0" y="0"/>
-          <a:ext cx="0" cy="0"/>
-          <a:chOff x="0" y="0"/>
-          <a:chExt cx="0" cy="0"/>
-        </a:xfrm>
-      </p:grpSpPr>
-      <p:sp>
-        <p:nvSpPr>
-          <p:cNvPr id="2" name="Title 1">
-            <a:extLst>
-              <a:ext uri="{FF2B5EF4-FFF2-40B4-BE49-F238E27FC236}">
                 <a16:creationId xmlns:a16="http://schemas.microsoft.com/office/drawing/2014/main" id="{E0C7AF46-024E-4562-8F68-C61D925614DB}"/>
               </a:ext>
             </a:extLst>
@@ -4378,7 +4059,7 @@
 </p:sld>
 </file>
 
-<file path=ppt/slides/slide7.xml><?xml version="1.0" encoding="utf-8"?>
+<file path=ppt/slides/slide5.xml><?xml version="1.0" encoding="utf-8"?>
 <p:sld xmlns:a="http://schemas.openxmlformats.org/drawingml/2006/main" xmlns:r="http://schemas.openxmlformats.org/officeDocument/2006/relationships" xmlns:p="http://schemas.openxmlformats.org/presentationml/2006/main">
   <p:cSld>
     <p:spTree>

</xml_diff>